<commit_message>
Update presentation: add contents slide and thank you slide, adjust total slide count
</commit_message>
<xml_diff>
--- a/Thesis_Final/Presentation/Hairfall_Presentation.pptx
+++ b/Thesis_Final/Presentation/Hairfall_Presentation.pptx
@@ -19,6 +19,8 @@
     <p:sldId id="267" r:id="rId19"/>
     <p:sldId id="268" r:id="rId20"/>
     <p:sldId id="269" r:id="rId21"/>
+    <p:sldId id="270" r:id="rId22"/>
+    <p:sldId id="271" r:id="rId23"/>
   </p:sldIdLst>
   <p:sldSz cx="12191695" cy="6858000" type="screen4x3"/>
   <p:notesSz cx="6858000" cy="9144000"/>
@@ -585,7 +587,7 @@
           <a:lstStyle/>
           <a:p>
             <a:r>
-              <a:t>One pipeline: clean and split the data once, give the same rows to the three models, evaluate them the same way, and explain each with SHAP. The 500 and 2,000 record sets show behaviour with little data.</a:t>
+              <a:t>Two public datasets are the sources. A super dataset of 200,000 records holds all their fields plus extra fields. Age and gender are identified in it. Comparing it with the two datasets gives the final dataset of 21,606 records used for modelling.</a:t>
             </a:r>
           </a:p>
         </p:txBody>
@@ -655,7 +657,7 @@
           <a:lstStyle/>
           <a:p>
             <a:r>
-              <a:t>Three different ways to predict. CatBoost needs training and tuning. TabPFN and TabFM only read the training rows as context and predict, so they need no tuning.</a:t>
+              <a:t>One pipeline: clean and split the data once, give the same rows to the three models, evaluate them the same way, and explain each with SHAP. The 500 and 2,000 record sets show behaviour with little data.</a:t>
             </a:r>
           </a:p>
         </p:txBody>
@@ -725,7 +727,7 @@
           <a:lstStyle/>
           <a:p>
             <a:r>
-              <a:t>SHAP shows which features push each prediction up or down. Metrics are macro averages because the tiers are not equal in size. McNemar's test tells us if differences are real.</a:t>
+              <a:t>Three different ways to predict. CatBoost needs training and tuning. TabPFN and TabFM only read the training rows as context and predict, so they need no tuning.</a:t>
             </a:r>
           </a:p>
         </p:txBody>
@@ -795,7 +797,7 @@
           <a:lstStyle/>
           <a:p>
             <a:r>
-              <a:t>These are expectations to test, not results. The study can also show the opposite, and a difference counts only if McNemar's test supports it.</a:t>
+              <a:t>SHAP shows which features push each prediction up or down. Metrics are macro averages because the tiers are not equal in size. McNemar's test tells us if differences are real.</a:t>
             </a:r>
           </a:p>
         </p:txBody>
@@ -865,7 +867,147 @@
           <a:lstStyle/>
           <a:p>
             <a:r>
+              <a:t>These are expectations to test, not results. The study can also show the opposite, and a difference counts only if McNemar's test supports it.</a:t>
+            </a:r>
+          </a:p>
+        </p:txBody>
+      </p:sp>
+      <p:sp>
+        <p:nvSpPr>
+          <p:cNvPr id="4" name="Slide Number Placeholder 3"/>
+          <p:cNvSpPr>
+            <a:spLocks noGrp="1"/>
+          </p:cNvSpPr>
+          <p:nvPr>
+            <p:ph type="sldNum" idx="5" sz="quarter"/>
+          </p:nvPr>
+        </p:nvSpPr>
+        <p:spPr/>
+      </p:sp>
+    </p:spTree>
+  </p:cSld>
+  <p:clrMapOvr>
+    <a:masterClrMapping/>
+  </p:clrMapOvr>
+</p:notes>
+</file>
+
+<file path=ppt/notesSlides/notesSlide15.xml><?xml version="1.0" encoding="utf-8"?>
+<p:notes xmlns:a="http://schemas.openxmlformats.org/drawingml/2006/main" xmlns:p="http://schemas.openxmlformats.org/presentationml/2006/main" xmlns:r="http://schemas.openxmlformats.org/officeDocument/2006/relationships">
+  <p:cSld>
+    <p:spTree>
+      <p:nvGrpSpPr>
+        <p:cNvPr id="1" name=""/>
+        <p:cNvGrpSpPr/>
+        <p:nvPr/>
+      </p:nvGrpSpPr>
+      <p:grpSpPr>
+        <a:xfrm>
+          <a:off x="0" y="0"/>
+          <a:ext cx="0" cy="0"/>
+          <a:chOff x="0" y="0"/>
+          <a:chExt cx="0" cy="0"/>
+        </a:xfrm>
+      </p:grpSpPr>
+      <p:sp>
+        <p:nvSpPr>
+          <p:cNvPr id="2" name="Slide Image Placeholder 1"/>
+          <p:cNvSpPr>
+            <a:spLocks noGrp="1"/>
+          </p:cNvSpPr>
+          <p:nvPr>
+            <p:ph type="sldImg" idx="2"/>
+          </p:nvPr>
+        </p:nvSpPr>
+        <p:spPr/>
+      </p:sp>
+      <p:sp>
+        <p:nvSpPr>
+          <p:cNvPr id="3" name="Notes Placeholder 2"/>
+          <p:cNvSpPr>
+            <a:spLocks noGrp="1"/>
+          </p:cNvSpPr>
+          <p:nvPr>
+            <p:ph type="body" idx="3" sz="quarter"/>
+          </p:nvPr>
+        </p:nvSpPr>
+        <p:spPr/>
+        <p:txBody>
+          <a:bodyPr/>
+          <a:lstStyle/>
+          <a:p>
+            <a:r>
               <a:t>Months 1 and 2 are the proposal work. Months 3 and 4 are the final work after approval, in the order of the methodology. Thank you; questions are welcome.</a:t>
+            </a:r>
+          </a:p>
+        </p:txBody>
+      </p:sp>
+      <p:sp>
+        <p:nvSpPr>
+          <p:cNvPr id="4" name="Slide Number Placeholder 3"/>
+          <p:cNvSpPr>
+            <a:spLocks noGrp="1"/>
+          </p:cNvSpPr>
+          <p:nvPr>
+            <p:ph type="sldNum" idx="5" sz="quarter"/>
+          </p:nvPr>
+        </p:nvSpPr>
+        <p:spPr/>
+      </p:sp>
+    </p:spTree>
+  </p:cSld>
+  <p:clrMapOvr>
+    <a:masterClrMapping/>
+  </p:clrMapOvr>
+</p:notes>
+</file>
+
+<file path=ppt/notesSlides/notesSlide16.xml><?xml version="1.0" encoding="utf-8"?>
+<p:notes xmlns:a="http://schemas.openxmlformats.org/drawingml/2006/main" xmlns:p="http://schemas.openxmlformats.org/presentationml/2006/main" xmlns:r="http://schemas.openxmlformats.org/officeDocument/2006/relationships">
+  <p:cSld>
+    <p:spTree>
+      <p:nvGrpSpPr>
+        <p:cNvPr id="1" name=""/>
+        <p:cNvGrpSpPr/>
+        <p:nvPr/>
+      </p:nvGrpSpPr>
+      <p:grpSpPr>
+        <a:xfrm>
+          <a:off x="0" y="0"/>
+          <a:ext cx="0" cy="0"/>
+          <a:chOff x="0" y="0"/>
+          <a:chExt cx="0" cy="0"/>
+        </a:xfrm>
+      </p:grpSpPr>
+      <p:sp>
+        <p:nvSpPr>
+          <p:cNvPr id="2" name="Slide Image Placeholder 1"/>
+          <p:cNvSpPr>
+            <a:spLocks noGrp="1"/>
+          </p:cNvSpPr>
+          <p:nvPr>
+            <p:ph type="sldImg" idx="2"/>
+          </p:nvPr>
+        </p:nvSpPr>
+        <p:spPr/>
+      </p:sp>
+      <p:sp>
+        <p:nvSpPr>
+          <p:cNvPr id="3" name="Notes Placeholder 2"/>
+          <p:cNvSpPr>
+            <a:spLocks noGrp="1"/>
+          </p:cNvSpPr>
+          <p:nvPr>
+            <p:ph type="body" idx="3" sz="quarter"/>
+          </p:nvPr>
+        </p:nvSpPr>
+        <p:spPr/>
+        <p:txBody>
+          <a:bodyPr/>
+          <a:lstStyle/>
+          <a:p>
+            <a:r>
+              <a:t>Thank the panel and invite questions.</a:t>
             </a:r>
           </a:p>
         </p:txBody>
@@ -935,7 +1077,7 @@
           <a:lstStyle/>
           <a:p>
             <a:r>
-              <a:t>One-slide summary. Problem, aim, data, method, expected result and time. Each point is explained on the next slides.</a:t>
+              <a:t>This is the outline of the talk: the problem, what is known, the gap, the data and methods, what we expect, and the schedule.</a:t>
             </a:r>
           </a:p>
         </p:txBody>
@@ -1005,7 +1147,7 @@
           <a:lstStyle/>
           <a:p>
             <a:r>
-              <a:t>Hair loss has many causes that act together, so one test cannot predict it. Doctors rely on history and self-reports. ML can help but is a black box, which is a problem in health care.</a:t>
+              <a:t>One-slide summary. Problem, aim, data, method, expected result and time. Each point is explained on the next slides.</a:t>
             </a:r>
           </a:p>
         </p:txBody>
@@ -1075,7 +1217,7 @@
           <a:lstStyle/>
           <a:p>
             <a:r>
-              <a:t>Two objectives: compare the three models, and explain them. Everything in the project serves one of these two.</a:t>
+              <a:t>Hair loss has many causes that act together, so one test cannot predict it. Doctors rely on history and self-reports. ML can help but is a black box, which is a problem in health care.</a:t>
             </a:r>
           </a:p>
         </p:txBody>
@@ -1145,7 +1287,7 @@
           <a:lstStyle/>
           <a:p>
             <a:r>
-              <a:t>Hair grows in cycles. Anything that pushes follicles out of the growth phase early causes shedding. These factors overlap, which is why a model that combines many indicators is useful.</a:t>
+              <a:t>Two objectives: compare the three models, and explain them. Everything in the project serves one of these two.</a:t>
             </a:r>
           </a:p>
         </p:txBody>
@@ -1215,7 +1357,7 @@
           <a:lstStyle/>
           <a:p>
             <a:r>
-              <a:t>These are the closest studies. Most use classical models on survey data, or images. Results differ a lot between studies, and explanations were not compared.</a:t>
+              <a:t>Hair grows in cycles. Anything that pushes follicles out of the growth phase early causes shedding. These factors overlap, which is why a model that combines many indicators is useful.</a:t>
             </a:r>
           </a:p>
         </p:txBody>
@@ -1285,7 +1427,7 @@
           <a:lstStyle/>
           <a:p>
             <a:r>
-              <a:t>CatBoost is a strong boosted-tree model for categorical data. TabPFN and TabFM are new foundation models: pretrained once, then they predict in one pass without training.</a:t>
+              <a:t>These are the closest studies. Most use classical models on survey data, or images. Results differ a lot between studies, and explanations were not compared.</a:t>
             </a:r>
           </a:p>
         </p:txBody>
@@ -1355,7 +1497,7 @@
           <a:lstStyle/>
           <a:p>
             <a:r>
-              <a:t>This is what we found missing in the literature. It is why the project compares these three models and explains them.</a:t>
+              <a:t>CatBoost is a strong boosted-tree model for categorical data. TabPFN and TabFM are new foundation models: pretrained once, then they predict in one pass without training.</a:t>
             </a:r>
           </a:p>
         </p:txBody>
@@ -1425,7 +1567,7 @@
           <a:lstStyle/>
           <a:p>
             <a:r>
-              <a:t>Two public datasets are the sources. A super dataset of 200,000 records holds all their fields plus extra fields. Age and gender are identified in it. Comparing it with the two datasets gives the final dataset of 21,606 records used for modelling.</a:t>
+              <a:t>This is what we found missing in the literature. It is why the project compares these three models and explains them.</a:t>
             </a:r>
           </a:p>
         </p:txBody>
@@ -4707,7 +4849,7 @@
                 </a:solidFill>
                 <a:latin typeface="Arial"/>
               </a:rPr>
-              <a:t>Research framework</a:t>
+              <a:t>Data</a:t>
             </a:r>
           </a:p>
         </p:txBody>
@@ -4820,14 +4962,101 @@
                 </a:solidFill>
                 <a:latin typeface="Arial"/>
               </a:rPr>
-              <a:t>10 / 14</a:t>
+              <a:t>10 / 16</a:t>
+            </a:r>
+          </a:p>
+        </p:txBody>
+      </p:sp>
+      <p:sp>
+        <p:nvSpPr>
+          <p:cNvPr id="6" name="TextBox 5"/>
+          <p:cNvSpPr txBox="1"/>
+          <p:nvPr/>
+        </p:nvSpPr>
+        <p:spPr>
+          <a:xfrm>
+            <a:off x="548640" y="1371600"/>
+            <a:ext cx="4572000" cy="4846320"/>
+          </a:xfrm>
+          <a:prstGeom prst="rect">
+            <a:avLst/>
+          </a:prstGeom>
+          <a:noFill/>
+        </p:spPr>
+        <p:txBody>
+          <a:bodyPr wrap="square" anchor="t" lIns="45720" rIns="45720">
+            <a:spAutoFit/>
+          </a:bodyPr>
+          <a:lstStyle/>
+          <a:p>
+            <a:pPr algn="l">
+              <a:spcAft>
+                <a:spcPts val="1200"/>
+              </a:spcAft>
+            </a:pPr>
+            <a:r>
+              <a:rPr sz="1700" b="0">
+                <a:solidFill>
+                  <a:srgbClr val="000000"/>
+                </a:solidFill>
+                <a:latin typeface="Arial"/>
+              </a:rPr>
+              <a:t>•  Dataset 1 (Kaggle): 100,000 records, 13 columns of measurements and hair fall (0 to 5).</a:t>
+            </a:r>
+          </a:p>
+          <a:p>
+            <a:pPr algn="l">
+              <a:spcAft>
+                <a:spcPts val="1200"/>
+              </a:spcAft>
+            </a:pPr>
+            <a:r>
+              <a:rPr sz="1700" b="0">
+                <a:solidFill>
+                  <a:srgbClr val="000000"/>
+                </a:solidFill>
+                <a:latin typeface="Arial"/>
+              </a:rPr>
+              <a:t>•  Dataset 2 (Mendeley): survey of 716 people, 14 columns.</a:t>
+            </a:r>
+          </a:p>
+          <a:p>
+            <a:pPr algn="l">
+              <a:spcAft>
+                <a:spcPts val="1200"/>
+              </a:spcAft>
+            </a:pPr>
+            <a:r>
+              <a:rPr sz="1700" b="0">
+                <a:solidFill>
+                  <a:srgbClr val="000000"/>
+                </a:solidFill>
+                <a:latin typeface="Arial"/>
+              </a:rPr>
+              <a:t>•  Super dataset: 200,000 records with all fields of both and extra fields.</a:t>
+            </a:r>
+          </a:p>
+          <a:p>
+            <a:pPr algn="l">
+              <a:spcAft>
+                <a:spcPts val="1200"/>
+              </a:spcAft>
+            </a:pPr>
+            <a:r>
+              <a:rPr sz="1700" b="0">
+                <a:solidFill>
+                  <a:srgbClr val="000000"/>
+                </a:solidFill>
+                <a:latin typeface="Arial"/>
+              </a:rPr>
+              <a:t>•  Final dataset: 21,606 records, 20 features, target Low 45%, Moderate 35%, High 20%.</a:t>
             </a:r>
           </a:p>
         </p:txBody>
       </p:sp>
       <p:pic>
         <p:nvPicPr>
-          <p:cNvPr id="6" name="Picture 5" descr="fig_3_1_framework.png"/>
+          <p:cNvPr id="7" name="Picture 6" descr="fig_3_2_dataset_link.png"/>
           <p:cNvPicPr>
             <a:picLocks noChangeAspect="1"/>
           </p:cNvPicPr>
@@ -4841,53 +5070,14 @@
         </p:blipFill>
         <p:spPr>
           <a:xfrm>
-            <a:off x="1737360" y="1371600"/>
-            <a:ext cx="8686800" cy="3750768"/>
+            <a:off x="5212080" y="2194560"/>
+            <a:ext cx="6675120" cy="2853550"/>
           </a:xfrm>
           <a:prstGeom prst="rect">
             <a:avLst/>
           </a:prstGeom>
         </p:spPr>
       </p:pic>
-      <p:sp>
-        <p:nvSpPr>
-          <p:cNvPr id="7" name="TextBox 6"/>
-          <p:cNvSpPr txBox="1"/>
-          <p:nvPr/>
-        </p:nvSpPr>
-        <p:spPr>
-          <a:xfrm>
-            <a:off x="822960" y="5760720"/>
-            <a:ext cx="10515600" cy="548640"/>
-          </a:xfrm>
-          <a:prstGeom prst="rect">
-            <a:avLst/>
-          </a:prstGeom>
-          <a:noFill/>
-        </p:spPr>
-        <p:txBody>
-          <a:bodyPr wrap="square" anchor="t" lIns="45720" rIns="45720">
-            <a:spAutoFit/>
-          </a:bodyPr>
-          <a:lstStyle/>
-          <a:p>
-            <a:pPr algn="ctr">
-              <a:spcAft>
-                <a:spcPts val="800"/>
-              </a:spcAft>
-            </a:pPr>
-            <a:r>
-              <a:rPr sz="1600" b="0">
-                <a:solidFill>
-                  <a:srgbClr val="000000"/>
-                </a:solidFill>
-                <a:latin typeface="Arial"/>
-              </a:rPr>
-              <a:t>Same split and seed for all models. Training sizes: 500, 2,000, and all 17,284 records.</a:t>
-            </a:r>
-          </a:p>
-        </p:txBody>
-      </p:sp>
     </p:spTree>
   </p:cSld>
   <p:clrMapOvr>
@@ -4940,7 +5130,7 @@
                 </a:solidFill>
                 <a:latin typeface="Arial"/>
               </a:rPr>
-              <a:t>Models</a:t>
+              <a:t>Research framework</a:t>
             </a:r>
           </a:p>
         </p:txBody>
@@ -5053,7 +5243,240 @@
                 </a:solidFill>
                 <a:latin typeface="Arial"/>
               </a:rPr>
-              <a:t>11 / 14</a:t>
+              <a:t>11 / 16</a:t>
+            </a:r>
+          </a:p>
+        </p:txBody>
+      </p:sp>
+      <p:pic>
+        <p:nvPicPr>
+          <p:cNvPr id="6" name="Picture 5" descr="fig_3_1_framework.png"/>
+          <p:cNvPicPr>
+            <a:picLocks noChangeAspect="1"/>
+          </p:cNvPicPr>
+          <p:nvPr/>
+        </p:nvPicPr>
+        <p:blipFill>
+          <a:blip r:embed="rId3"/>
+          <a:stretch>
+            <a:fillRect/>
+          </a:stretch>
+        </p:blipFill>
+        <p:spPr>
+          <a:xfrm>
+            <a:off x="1737360" y="1371600"/>
+            <a:ext cx="8686800" cy="3750768"/>
+          </a:xfrm>
+          <a:prstGeom prst="rect">
+            <a:avLst/>
+          </a:prstGeom>
+        </p:spPr>
+      </p:pic>
+      <p:sp>
+        <p:nvSpPr>
+          <p:cNvPr id="7" name="TextBox 6"/>
+          <p:cNvSpPr txBox="1"/>
+          <p:nvPr/>
+        </p:nvSpPr>
+        <p:spPr>
+          <a:xfrm>
+            <a:off x="822960" y="5760720"/>
+            <a:ext cx="10515600" cy="548640"/>
+          </a:xfrm>
+          <a:prstGeom prst="rect">
+            <a:avLst/>
+          </a:prstGeom>
+          <a:noFill/>
+        </p:spPr>
+        <p:txBody>
+          <a:bodyPr wrap="square" anchor="t" lIns="45720" rIns="45720">
+            <a:spAutoFit/>
+          </a:bodyPr>
+          <a:lstStyle/>
+          <a:p>
+            <a:pPr algn="ctr">
+              <a:spcAft>
+                <a:spcPts val="800"/>
+              </a:spcAft>
+            </a:pPr>
+            <a:r>
+              <a:rPr sz="1600" b="0">
+                <a:solidFill>
+                  <a:srgbClr val="000000"/>
+                </a:solidFill>
+                <a:latin typeface="Arial"/>
+              </a:rPr>
+              <a:t>Same split and seed for all models. Training sizes: 500, 2,000, and all 17,284 records.</a:t>
+            </a:r>
+          </a:p>
+        </p:txBody>
+      </p:sp>
+    </p:spTree>
+  </p:cSld>
+  <p:clrMapOvr>
+    <a:masterClrMapping/>
+  </p:clrMapOvr>
+</p:sld>
+</file>
+
+<file path=ppt/slides/slide12.xml><?xml version="1.0" encoding="utf-8"?>
+<p:sld xmlns:a="http://schemas.openxmlformats.org/drawingml/2006/main" xmlns:p="http://schemas.openxmlformats.org/presentationml/2006/main" xmlns:r="http://schemas.openxmlformats.org/officeDocument/2006/relationships">
+  <p:cSld>
+    <p:spTree>
+      <p:nvGrpSpPr>
+        <p:cNvPr id="1" name=""/>
+        <p:cNvGrpSpPr/>
+        <p:nvPr/>
+      </p:nvGrpSpPr>
+      <p:grpSpPr/>
+      <p:sp>
+        <p:nvSpPr>
+          <p:cNvPr id="2" name="TextBox 1"/>
+          <p:cNvSpPr txBox="1"/>
+          <p:nvPr/>
+        </p:nvSpPr>
+        <p:spPr>
+          <a:xfrm>
+            <a:off x="548640" y="320040"/>
+            <a:ext cx="11064240" cy="822960"/>
+          </a:xfrm>
+          <a:prstGeom prst="rect">
+            <a:avLst/>
+          </a:prstGeom>
+          <a:noFill/>
+        </p:spPr>
+        <p:txBody>
+          <a:bodyPr wrap="square" anchor="ctr" lIns="45720" rIns="45720">
+            <a:spAutoFit/>
+          </a:bodyPr>
+          <a:lstStyle/>
+          <a:p>
+            <a:pPr algn="l">
+              <a:spcAft>
+                <a:spcPts val="800"/>
+              </a:spcAft>
+            </a:pPr>
+            <a:r>
+              <a:rPr sz="3200" b="1">
+                <a:solidFill>
+                  <a:srgbClr val="000000"/>
+                </a:solidFill>
+                <a:latin typeface="Arial"/>
+              </a:rPr>
+              <a:t>Models</a:t>
+            </a:r>
+          </a:p>
+        </p:txBody>
+      </p:sp>
+      <p:cxnSp>
+        <p:nvCxnSpPr>
+          <p:cNvPr id="3" name="Connector 2"/>
+          <p:cNvCxnSpPr/>
+          <p:nvPr/>
+        </p:nvCxnSpPr>
+        <p:spPr>
+          <a:xfrm>
+            <a:off x="594360" y="1143000"/>
+            <a:ext cx="10972800" cy="0"/>
+          </a:xfrm>
+          <a:prstGeom prst="line">
+            <a:avLst/>
+          </a:prstGeom>
+          <a:ln w="15875">
+            <a:solidFill>
+              <a:srgbClr val="000000"/>
+            </a:solidFill>
+          </a:ln>
+        </p:spPr>
+        <p:style>
+          <a:lnRef idx="2">
+            <a:schemeClr val="accent1"/>
+          </a:lnRef>
+          <a:fillRef idx="0">
+            <a:schemeClr val="accent1"/>
+          </a:fillRef>
+          <a:effectRef idx="1">
+            <a:schemeClr val="accent1"/>
+          </a:effectRef>
+          <a:fontRef idx="minor">
+            <a:schemeClr val="tx1"/>
+          </a:fontRef>
+        </p:style>
+      </p:cxnSp>
+      <p:sp>
+        <p:nvSpPr>
+          <p:cNvPr id="4" name="TextBox 3"/>
+          <p:cNvSpPr txBox="1"/>
+          <p:nvPr/>
+        </p:nvSpPr>
+        <p:spPr>
+          <a:xfrm>
+            <a:off x="548640" y="6400800"/>
+            <a:ext cx="8229600" cy="320040"/>
+          </a:xfrm>
+          <a:prstGeom prst="rect">
+            <a:avLst/>
+          </a:prstGeom>
+          <a:noFill/>
+        </p:spPr>
+        <p:txBody>
+          <a:bodyPr wrap="square" anchor="t" lIns="45720" rIns="45720">
+            <a:spAutoFit/>
+          </a:bodyPr>
+          <a:lstStyle/>
+          <a:p>
+            <a:pPr algn="l">
+              <a:spcAft>
+                <a:spcPts val="800"/>
+              </a:spcAft>
+            </a:pPr>
+            <a:r>
+              <a:rPr sz="1100" b="0">
+                <a:solidFill>
+                  <a:srgbClr val="595959"/>
+                </a:solidFill>
+                <a:latin typeface="Arial"/>
+              </a:rPr>
+              <a:t>Comparing CatBoost, TabPFN, and TabFM for Explainable Hair Fall Risk Prediction</a:t>
+            </a:r>
+          </a:p>
+        </p:txBody>
+      </p:sp>
+      <p:sp>
+        <p:nvSpPr>
+          <p:cNvPr id="5" name="TextBox 4"/>
+          <p:cNvSpPr txBox="1"/>
+          <p:nvPr/>
+        </p:nvSpPr>
+        <p:spPr>
+          <a:xfrm>
+            <a:off x="10698480" y="6400800"/>
+            <a:ext cx="914400" cy="320040"/>
+          </a:xfrm>
+          <a:prstGeom prst="rect">
+            <a:avLst/>
+          </a:prstGeom>
+          <a:noFill/>
+        </p:spPr>
+        <p:txBody>
+          <a:bodyPr wrap="square" anchor="t" lIns="45720" rIns="45720">
+            <a:spAutoFit/>
+          </a:bodyPr>
+          <a:lstStyle/>
+          <a:p>
+            <a:pPr algn="r">
+              <a:spcAft>
+                <a:spcPts val="800"/>
+              </a:spcAft>
+            </a:pPr>
+            <a:r>
+              <a:rPr sz="1100" b="0">
+                <a:solidFill>
+                  <a:srgbClr val="595959"/>
+                </a:solidFill>
+                <a:latin typeface="Arial"/>
+              </a:rPr>
+              <a:t>12 / 16</a:t>
             </a:r>
           </a:p>
         </p:txBody>
@@ -5692,7 +6115,7 @@
 </p:sld>
 </file>
 
-<file path=ppt/slides/slide12.xml><?xml version="1.0" encoding="utf-8"?>
+<file path=ppt/slides/slide13.xml><?xml version="1.0" encoding="utf-8"?>
 <p:sld xmlns:a="http://schemas.openxmlformats.org/drawingml/2006/main" xmlns:p="http://schemas.openxmlformats.org/presentationml/2006/main" xmlns:r="http://schemas.openxmlformats.org/officeDocument/2006/relationships">
   <p:cSld>
     <p:spTree>
@@ -5849,7 +6272,7 @@
                 </a:solidFill>
                 <a:latin typeface="Arial"/>
               </a:rPr>
-              <a:t>12 / 14</a:t>
+              <a:t>13 / 16</a:t>
             </a:r>
           </a:p>
         </p:txBody>
@@ -6052,7 +6475,7 @@
 </p:sld>
 </file>
 
-<file path=ppt/slides/slide13.xml><?xml version="1.0" encoding="utf-8"?>
+<file path=ppt/slides/slide14.xml><?xml version="1.0" encoding="utf-8"?>
 <p:sld xmlns:a="http://schemas.openxmlformats.org/drawingml/2006/main" xmlns:p="http://schemas.openxmlformats.org/presentationml/2006/main" xmlns:r="http://schemas.openxmlformats.org/officeDocument/2006/relationships">
   <p:cSld>
     <p:spTree>
@@ -6209,7 +6632,7 @@
                 </a:solidFill>
                 <a:latin typeface="Arial"/>
               </a:rPr>
-              <a:t>13 / 14</a:t>
+              <a:t>14 / 16</a:t>
             </a:r>
           </a:p>
         </p:txBody>
@@ -6325,7 +6748,7 @@
 </p:sld>
 </file>
 
-<file path=ppt/slides/slide14.xml><?xml version="1.0" encoding="utf-8"?>
+<file path=ppt/slides/slide15.xml><?xml version="1.0" encoding="utf-8"?>
 <p:sld xmlns:a="http://schemas.openxmlformats.org/drawingml/2006/main" xmlns:p="http://schemas.openxmlformats.org/presentationml/2006/main" xmlns:r="http://schemas.openxmlformats.org/officeDocument/2006/relationships">
   <p:cSld>
     <p:spTree>
@@ -6482,7 +6905,7 @@
                 </a:solidFill>
                 <a:latin typeface="Arial"/>
               </a:rPr>
-              <a:t>14 / 14</a:t>
+              <a:t>15 / 16</a:t>
             </a:r>
           </a:p>
         </p:txBody>
@@ -6519,6 +6942,192 @@
 </p:sld>
 </file>
 
+<file path=ppt/slides/slide16.xml><?xml version="1.0" encoding="utf-8"?>
+<p:sld xmlns:a="http://schemas.openxmlformats.org/drawingml/2006/main" xmlns:p="http://schemas.openxmlformats.org/presentationml/2006/main" xmlns:r="http://schemas.openxmlformats.org/officeDocument/2006/relationships">
+  <p:cSld>
+    <p:spTree>
+      <p:nvGrpSpPr>
+        <p:cNvPr id="1" name=""/>
+        <p:cNvGrpSpPr/>
+        <p:nvPr/>
+      </p:nvGrpSpPr>
+      <p:grpSpPr/>
+      <p:sp>
+        <p:nvSpPr>
+          <p:cNvPr id="2" name="TextBox 1"/>
+          <p:cNvSpPr txBox="1"/>
+          <p:nvPr/>
+        </p:nvSpPr>
+        <p:spPr>
+          <a:xfrm>
+            <a:off x="731520" y="2103120"/>
+            <a:ext cx="10698480" cy="1280160"/>
+          </a:xfrm>
+          <a:prstGeom prst="rect">
+            <a:avLst/>
+          </a:prstGeom>
+          <a:noFill/>
+        </p:spPr>
+        <p:txBody>
+          <a:bodyPr wrap="square" anchor="ctr" lIns="45720" rIns="45720">
+            <a:spAutoFit/>
+          </a:bodyPr>
+          <a:lstStyle/>
+          <a:p>
+            <a:pPr algn="ctr">
+              <a:spcAft>
+                <a:spcPts val="800"/>
+              </a:spcAft>
+            </a:pPr>
+            <a:r>
+              <a:rPr sz="5400" b="1">
+                <a:solidFill>
+                  <a:srgbClr val="000000"/>
+                </a:solidFill>
+                <a:latin typeface="Arial"/>
+              </a:rPr>
+              <a:t>Thank you</a:t>
+            </a:r>
+          </a:p>
+        </p:txBody>
+      </p:sp>
+      <p:cxnSp>
+        <p:nvCxnSpPr>
+          <p:cNvPr id="3" name="Connector 2"/>
+          <p:cNvCxnSpPr/>
+          <p:nvPr/>
+        </p:nvCxnSpPr>
+        <p:spPr>
+          <a:xfrm>
+            <a:off x="3840480" y="3566160"/>
+            <a:ext cx="4572000" cy="0"/>
+          </a:xfrm>
+          <a:prstGeom prst="line">
+            <a:avLst/>
+          </a:prstGeom>
+          <a:ln w="15875">
+            <a:solidFill>
+              <a:srgbClr val="000000"/>
+            </a:solidFill>
+          </a:ln>
+        </p:spPr>
+        <p:style>
+          <a:lnRef idx="2">
+            <a:schemeClr val="accent1"/>
+          </a:lnRef>
+          <a:fillRef idx="0">
+            <a:schemeClr val="accent1"/>
+          </a:fillRef>
+          <a:effectRef idx="1">
+            <a:schemeClr val="accent1"/>
+          </a:effectRef>
+          <a:fontRef idx="minor">
+            <a:schemeClr val="tx1"/>
+          </a:fontRef>
+        </p:style>
+      </p:cxnSp>
+      <p:sp>
+        <p:nvSpPr>
+          <p:cNvPr id="4" name="TextBox 3"/>
+          <p:cNvSpPr txBox="1"/>
+          <p:nvPr/>
+        </p:nvSpPr>
+        <p:spPr>
+          <a:xfrm>
+            <a:off x="731520" y="3749039"/>
+            <a:ext cx="10698480" cy="1097280"/>
+          </a:xfrm>
+          <a:prstGeom prst="rect">
+            <a:avLst/>
+          </a:prstGeom>
+          <a:noFill/>
+        </p:spPr>
+        <p:txBody>
+          <a:bodyPr wrap="square" anchor="t" lIns="45720" rIns="45720">
+            <a:spAutoFit/>
+          </a:bodyPr>
+          <a:lstStyle/>
+          <a:p>
+            <a:pPr algn="ctr">
+              <a:spcAft>
+                <a:spcPts val="800"/>
+              </a:spcAft>
+            </a:pPr>
+            <a:r>
+              <a:rPr sz="2000" b="0">
+                <a:solidFill>
+                  <a:srgbClr val="000000"/>
+                </a:solidFill>
+                <a:latin typeface="Arial"/>
+              </a:rPr>
+              <a:t>Questions are welcome</a:t>
+            </a:r>
+          </a:p>
+          <a:p>
+            <a:pPr algn="ctr">
+              <a:spcAft>
+                <a:spcPts val="800"/>
+              </a:spcAft>
+            </a:pPr>
+            <a:r>
+              <a:rPr sz="2000" b="0">
+                <a:solidFill>
+                  <a:srgbClr val="000000"/>
+                </a:solidFill>
+                <a:latin typeface="Arial"/>
+              </a:rPr>
+              <a:t>Nirajan Shahi  |  Supervisor: Asst. Prof. Jagadish Bhatta</a:t>
+            </a:r>
+          </a:p>
+        </p:txBody>
+      </p:sp>
+      <p:sp>
+        <p:nvSpPr>
+          <p:cNvPr id="5" name="TextBox 4"/>
+          <p:cNvSpPr txBox="1"/>
+          <p:nvPr/>
+        </p:nvSpPr>
+        <p:spPr>
+          <a:xfrm>
+            <a:off x="10698480" y="6400800"/>
+            <a:ext cx="914400" cy="320040"/>
+          </a:xfrm>
+          <a:prstGeom prst="rect">
+            <a:avLst/>
+          </a:prstGeom>
+          <a:noFill/>
+        </p:spPr>
+        <p:txBody>
+          <a:bodyPr wrap="square" anchor="t" lIns="45720" rIns="45720">
+            <a:spAutoFit/>
+          </a:bodyPr>
+          <a:lstStyle/>
+          <a:p>
+            <a:pPr algn="r">
+              <a:spcAft>
+                <a:spcPts val="800"/>
+              </a:spcAft>
+            </a:pPr>
+            <a:r>
+              <a:rPr sz="1100" b="0">
+                <a:solidFill>
+                  <a:srgbClr val="595959"/>
+                </a:solidFill>
+                <a:latin typeface="Arial"/>
+              </a:rPr>
+              <a:t>16 / 16</a:t>
+            </a:r>
+          </a:p>
+        </p:txBody>
+      </p:sp>
+    </p:spTree>
+  </p:cSld>
+  <p:clrMapOvr>
+    <a:masterClrMapping/>
+  </p:clrMapOvr>
+</p:sld>
+</file>
+
 <file path=ppt/slides/slide2.xml><?xml version="1.0" encoding="utf-8"?>
 <p:sld xmlns:a="http://schemas.openxmlformats.org/drawingml/2006/main" xmlns:p="http://schemas.openxmlformats.org/presentationml/2006/main" xmlns:r="http://schemas.openxmlformats.org/officeDocument/2006/relationships">
   <p:cSld>
@@ -6563,7 +7172,7 @@
                 </a:solidFill>
                 <a:latin typeface="Arial"/>
               </a:rPr>
-              <a:t>Project at a glance</a:t>
+              <a:t>Contents</a:t>
             </a:r>
           </a:p>
         </p:txBody>
@@ -6676,7 +7285,955 @@
                 </a:solidFill>
                 <a:latin typeface="Arial"/>
               </a:rPr>
-              <a:t>2 / 14</a:t>
+              <a:t>2 / 16</a:t>
+            </a:r>
+          </a:p>
+        </p:txBody>
+      </p:sp>
+      <p:graphicFrame>
+        <p:nvGraphicFramePr>
+          <p:cNvPr id="6" name="Table 5"/>
+          <p:cNvGraphicFramePr>
+            <a:graphicFrameLocks noGrp="1"/>
+          </p:cNvGraphicFramePr>
+          <p:nvPr/>
+        </p:nvGraphicFramePr>
+        <p:xfrm>
+          <a:off x="2011680" y="1463040"/>
+          <a:ext cx="8138160" cy="4389120"/>
+        </p:xfrm>
+        <a:graphic>
+          <a:graphicData uri="http://schemas.openxmlformats.org/drawingml/2006/table">
+            <a:tbl>
+              <a:tblPr firstRow="0" bandRow="0">
+                <a:tableStyleId>{5940675A-B579-460E-94D1-54222C63F5DA}</a:tableStyleId>
+              </a:tblPr>
+              <a:tblGrid>
+                <a:gridCol w="6400800"/>
+                <a:gridCol w="1737360"/>
+              </a:tblGrid>
+              <a:tr h="548640">
+                <a:tc>
+                  <a:txBody>
+                    <a:bodyPr wrap="square"/>
+                    <a:lstStyle/>
+                    <a:p>
+                      <a:r>
+                        <a:rPr sz="2000" b="1">
+                          <a:solidFill>
+                            <a:srgbClr val="000000"/>
+                          </a:solidFill>
+                          <a:latin typeface="Arial"/>
+                        </a:rPr>
+                        <a:t>Topic</a:t>
+                      </a:r>
+                    </a:p>
+                  </a:txBody>
+                  <a:tcPr marL="73152" marR="73152" marT="36576" marB="36576">
+                    <a:solidFill>
+                      <a:srgbClr val="EEEEEE"/>
+                    </a:solidFill>
+                    <a:lnL w="12700" cap="flat" cmpd="sng" algn="ctr">
+                      <a:solidFill>
+                        <a:srgbClr val="000000"/>
+                      </a:solidFill>
+                      <a:prstDash val="solid"/>
+                    </a:lnL>
+                    <a:lnR w="12700" cap="flat" cmpd="sng" algn="ctr">
+                      <a:solidFill>
+                        <a:srgbClr val="000000"/>
+                      </a:solidFill>
+                      <a:prstDash val="solid"/>
+                    </a:lnR>
+                    <a:lnT w="12700" cap="flat" cmpd="sng" algn="ctr">
+                      <a:solidFill>
+                        <a:srgbClr val="000000"/>
+                      </a:solidFill>
+                      <a:prstDash val="solid"/>
+                    </a:lnT>
+                    <a:lnB w="12700" cap="flat" cmpd="sng" algn="ctr">
+                      <a:solidFill>
+                        <a:srgbClr val="000000"/>
+                      </a:solidFill>
+                      <a:prstDash val="solid"/>
+                    </a:lnB>
+                  </a:tcPr>
+                </a:tc>
+                <a:tc>
+                  <a:txBody>
+                    <a:bodyPr wrap="square"/>
+                    <a:lstStyle/>
+                    <a:p>
+                      <a:r>
+                        <a:rPr sz="2000" b="1">
+                          <a:solidFill>
+                            <a:srgbClr val="000000"/>
+                          </a:solidFill>
+                          <a:latin typeface="Arial"/>
+                        </a:rPr>
+                        <a:t>Slides</a:t>
+                      </a:r>
+                    </a:p>
+                  </a:txBody>
+                  <a:tcPr marL="73152" marR="73152" marT="36576" marB="36576">
+                    <a:solidFill>
+                      <a:srgbClr val="EEEEEE"/>
+                    </a:solidFill>
+                    <a:lnL w="12700" cap="flat" cmpd="sng" algn="ctr">
+                      <a:solidFill>
+                        <a:srgbClr val="000000"/>
+                      </a:solidFill>
+                      <a:prstDash val="solid"/>
+                    </a:lnL>
+                    <a:lnR w="12700" cap="flat" cmpd="sng" algn="ctr">
+                      <a:solidFill>
+                        <a:srgbClr val="000000"/>
+                      </a:solidFill>
+                      <a:prstDash val="solid"/>
+                    </a:lnR>
+                    <a:lnT w="12700" cap="flat" cmpd="sng" algn="ctr">
+                      <a:solidFill>
+                        <a:srgbClr val="000000"/>
+                      </a:solidFill>
+                      <a:prstDash val="solid"/>
+                    </a:lnT>
+                    <a:lnB w="12700" cap="flat" cmpd="sng" algn="ctr">
+                      <a:solidFill>
+                        <a:srgbClr val="000000"/>
+                      </a:solidFill>
+                      <a:prstDash val="solid"/>
+                    </a:lnB>
+                  </a:tcPr>
+                </a:tc>
+              </a:tr>
+              <a:tr h="548640">
+                <a:tc>
+                  <a:txBody>
+                    <a:bodyPr wrap="square"/>
+                    <a:lstStyle/>
+                    <a:p>
+                      <a:r>
+                        <a:rPr sz="2000" b="0">
+                          <a:solidFill>
+                            <a:srgbClr val="000000"/>
+                          </a:solidFill>
+                          <a:latin typeface="Arial"/>
+                        </a:rPr>
+                        <a:t>1.  Project at a glance</a:t>
+                      </a:r>
+                    </a:p>
+                  </a:txBody>
+                  <a:tcPr marL="73152" marR="73152" marT="36576" marB="36576">
+                    <a:solidFill>
+                      <a:srgbClr val="FFFFFF"/>
+                    </a:solidFill>
+                    <a:lnL w="12700" cap="flat" cmpd="sng" algn="ctr">
+                      <a:solidFill>
+                        <a:srgbClr val="000000"/>
+                      </a:solidFill>
+                      <a:prstDash val="solid"/>
+                    </a:lnL>
+                    <a:lnR w="12700" cap="flat" cmpd="sng" algn="ctr">
+                      <a:solidFill>
+                        <a:srgbClr val="000000"/>
+                      </a:solidFill>
+                      <a:prstDash val="solid"/>
+                    </a:lnR>
+                    <a:lnT w="12700" cap="flat" cmpd="sng" algn="ctr">
+                      <a:solidFill>
+                        <a:srgbClr val="000000"/>
+                      </a:solidFill>
+                      <a:prstDash val="solid"/>
+                    </a:lnT>
+                    <a:lnB w="12700" cap="flat" cmpd="sng" algn="ctr">
+                      <a:solidFill>
+                        <a:srgbClr val="000000"/>
+                      </a:solidFill>
+                      <a:prstDash val="solid"/>
+                    </a:lnB>
+                  </a:tcPr>
+                </a:tc>
+                <a:tc>
+                  <a:txBody>
+                    <a:bodyPr wrap="square"/>
+                    <a:lstStyle/>
+                    <a:p>
+                      <a:r>
+                        <a:rPr sz="2000" b="0">
+                          <a:solidFill>
+                            <a:srgbClr val="000000"/>
+                          </a:solidFill>
+                          <a:latin typeface="Arial"/>
+                        </a:rPr>
+                        <a:t>3</a:t>
+                      </a:r>
+                    </a:p>
+                  </a:txBody>
+                  <a:tcPr marL="73152" marR="73152" marT="36576" marB="36576">
+                    <a:solidFill>
+                      <a:srgbClr val="FFFFFF"/>
+                    </a:solidFill>
+                    <a:lnL w="12700" cap="flat" cmpd="sng" algn="ctr">
+                      <a:solidFill>
+                        <a:srgbClr val="000000"/>
+                      </a:solidFill>
+                      <a:prstDash val="solid"/>
+                    </a:lnL>
+                    <a:lnR w="12700" cap="flat" cmpd="sng" algn="ctr">
+                      <a:solidFill>
+                        <a:srgbClr val="000000"/>
+                      </a:solidFill>
+                      <a:prstDash val="solid"/>
+                    </a:lnR>
+                    <a:lnT w="12700" cap="flat" cmpd="sng" algn="ctr">
+                      <a:solidFill>
+                        <a:srgbClr val="000000"/>
+                      </a:solidFill>
+                      <a:prstDash val="solid"/>
+                    </a:lnT>
+                    <a:lnB w="12700" cap="flat" cmpd="sng" algn="ctr">
+                      <a:solidFill>
+                        <a:srgbClr val="000000"/>
+                      </a:solidFill>
+                      <a:prstDash val="solid"/>
+                    </a:lnB>
+                  </a:tcPr>
+                </a:tc>
+              </a:tr>
+              <a:tr h="548640">
+                <a:tc>
+                  <a:txBody>
+                    <a:bodyPr wrap="square"/>
+                    <a:lstStyle/>
+                    <a:p>
+                      <a:r>
+                        <a:rPr sz="2000" b="0">
+                          <a:solidFill>
+                            <a:srgbClr val="000000"/>
+                          </a:solidFill>
+                          <a:latin typeface="Arial"/>
+                        </a:rPr>
+                        <a:t>2.  Problem statement and objectives</a:t>
+                      </a:r>
+                    </a:p>
+                  </a:txBody>
+                  <a:tcPr marL="73152" marR="73152" marT="36576" marB="36576">
+                    <a:solidFill>
+                      <a:srgbClr val="FFFFFF"/>
+                    </a:solidFill>
+                    <a:lnL w="12700" cap="flat" cmpd="sng" algn="ctr">
+                      <a:solidFill>
+                        <a:srgbClr val="000000"/>
+                      </a:solidFill>
+                      <a:prstDash val="solid"/>
+                    </a:lnL>
+                    <a:lnR w="12700" cap="flat" cmpd="sng" algn="ctr">
+                      <a:solidFill>
+                        <a:srgbClr val="000000"/>
+                      </a:solidFill>
+                      <a:prstDash val="solid"/>
+                    </a:lnR>
+                    <a:lnT w="12700" cap="flat" cmpd="sng" algn="ctr">
+                      <a:solidFill>
+                        <a:srgbClr val="000000"/>
+                      </a:solidFill>
+                      <a:prstDash val="solid"/>
+                    </a:lnT>
+                    <a:lnB w="12700" cap="flat" cmpd="sng" algn="ctr">
+                      <a:solidFill>
+                        <a:srgbClr val="000000"/>
+                      </a:solidFill>
+                      <a:prstDash val="solid"/>
+                    </a:lnB>
+                  </a:tcPr>
+                </a:tc>
+                <a:tc>
+                  <a:txBody>
+                    <a:bodyPr wrap="square"/>
+                    <a:lstStyle/>
+                    <a:p>
+                      <a:r>
+                        <a:rPr sz="2000" b="0">
+                          <a:solidFill>
+                            <a:srgbClr val="000000"/>
+                          </a:solidFill>
+                          <a:latin typeface="Arial"/>
+                        </a:rPr>
+                        <a:t>4 - 5</a:t>
+                      </a:r>
+                    </a:p>
+                  </a:txBody>
+                  <a:tcPr marL="73152" marR="73152" marT="36576" marB="36576">
+                    <a:solidFill>
+                      <a:srgbClr val="FFFFFF"/>
+                    </a:solidFill>
+                    <a:lnL w="12700" cap="flat" cmpd="sng" algn="ctr">
+                      <a:solidFill>
+                        <a:srgbClr val="000000"/>
+                      </a:solidFill>
+                      <a:prstDash val="solid"/>
+                    </a:lnL>
+                    <a:lnR w="12700" cap="flat" cmpd="sng" algn="ctr">
+                      <a:solidFill>
+                        <a:srgbClr val="000000"/>
+                      </a:solidFill>
+                      <a:prstDash val="solid"/>
+                    </a:lnR>
+                    <a:lnT w="12700" cap="flat" cmpd="sng" algn="ctr">
+                      <a:solidFill>
+                        <a:srgbClr val="000000"/>
+                      </a:solidFill>
+                      <a:prstDash val="solid"/>
+                    </a:lnT>
+                    <a:lnB w="12700" cap="flat" cmpd="sng" algn="ctr">
+                      <a:solidFill>
+                        <a:srgbClr val="000000"/>
+                      </a:solidFill>
+                      <a:prstDash val="solid"/>
+                    </a:lnB>
+                  </a:tcPr>
+                </a:tc>
+              </a:tr>
+              <a:tr h="548640">
+                <a:tc>
+                  <a:txBody>
+                    <a:bodyPr wrap="square"/>
+                    <a:lstStyle/>
+                    <a:p>
+                      <a:r>
+                        <a:rPr sz="2000" b="0">
+                          <a:solidFill>
+                            <a:srgbClr val="000000"/>
+                          </a:solidFill>
+                          <a:latin typeface="Arial"/>
+                        </a:rPr>
+                        <a:t>3.  Background and literature</a:t>
+                      </a:r>
+                    </a:p>
+                  </a:txBody>
+                  <a:tcPr marL="73152" marR="73152" marT="36576" marB="36576">
+                    <a:solidFill>
+                      <a:srgbClr val="FFFFFF"/>
+                    </a:solidFill>
+                    <a:lnL w="12700" cap="flat" cmpd="sng" algn="ctr">
+                      <a:solidFill>
+                        <a:srgbClr val="000000"/>
+                      </a:solidFill>
+                      <a:prstDash val="solid"/>
+                    </a:lnL>
+                    <a:lnR w="12700" cap="flat" cmpd="sng" algn="ctr">
+                      <a:solidFill>
+                        <a:srgbClr val="000000"/>
+                      </a:solidFill>
+                      <a:prstDash val="solid"/>
+                    </a:lnR>
+                    <a:lnT w="12700" cap="flat" cmpd="sng" algn="ctr">
+                      <a:solidFill>
+                        <a:srgbClr val="000000"/>
+                      </a:solidFill>
+                      <a:prstDash val="solid"/>
+                    </a:lnT>
+                    <a:lnB w="12700" cap="flat" cmpd="sng" algn="ctr">
+                      <a:solidFill>
+                        <a:srgbClr val="000000"/>
+                      </a:solidFill>
+                      <a:prstDash val="solid"/>
+                    </a:lnB>
+                  </a:tcPr>
+                </a:tc>
+                <a:tc>
+                  <a:txBody>
+                    <a:bodyPr wrap="square"/>
+                    <a:lstStyle/>
+                    <a:p>
+                      <a:r>
+                        <a:rPr sz="2000" b="0">
+                          <a:solidFill>
+                            <a:srgbClr val="000000"/>
+                          </a:solidFill>
+                          <a:latin typeface="Arial"/>
+                        </a:rPr>
+                        <a:t>6 - 8</a:t>
+                      </a:r>
+                    </a:p>
+                  </a:txBody>
+                  <a:tcPr marL="73152" marR="73152" marT="36576" marB="36576">
+                    <a:solidFill>
+                      <a:srgbClr val="FFFFFF"/>
+                    </a:solidFill>
+                    <a:lnL w="12700" cap="flat" cmpd="sng" algn="ctr">
+                      <a:solidFill>
+                        <a:srgbClr val="000000"/>
+                      </a:solidFill>
+                      <a:prstDash val="solid"/>
+                    </a:lnL>
+                    <a:lnR w="12700" cap="flat" cmpd="sng" algn="ctr">
+                      <a:solidFill>
+                        <a:srgbClr val="000000"/>
+                      </a:solidFill>
+                      <a:prstDash val="solid"/>
+                    </a:lnR>
+                    <a:lnT w="12700" cap="flat" cmpd="sng" algn="ctr">
+                      <a:solidFill>
+                        <a:srgbClr val="000000"/>
+                      </a:solidFill>
+                      <a:prstDash val="solid"/>
+                    </a:lnT>
+                    <a:lnB w="12700" cap="flat" cmpd="sng" algn="ctr">
+                      <a:solidFill>
+                        <a:srgbClr val="000000"/>
+                      </a:solidFill>
+                      <a:prstDash val="solid"/>
+                    </a:lnB>
+                  </a:tcPr>
+                </a:tc>
+              </a:tr>
+              <a:tr h="548640">
+                <a:tc>
+                  <a:txBody>
+                    <a:bodyPr wrap="square"/>
+                    <a:lstStyle/>
+                    <a:p>
+                      <a:r>
+                        <a:rPr sz="2000" b="0">
+                          <a:solidFill>
+                            <a:srgbClr val="000000"/>
+                          </a:solidFill>
+                          <a:latin typeface="Arial"/>
+                        </a:rPr>
+                        <a:t>4.  Research gap</a:t>
+                      </a:r>
+                    </a:p>
+                  </a:txBody>
+                  <a:tcPr marL="73152" marR="73152" marT="36576" marB="36576">
+                    <a:solidFill>
+                      <a:srgbClr val="FFFFFF"/>
+                    </a:solidFill>
+                    <a:lnL w="12700" cap="flat" cmpd="sng" algn="ctr">
+                      <a:solidFill>
+                        <a:srgbClr val="000000"/>
+                      </a:solidFill>
+                      <a:prstDash val="solid"/>
+                    </a:lnL>
+                    <a:lnR w="12700" cap="flat" cmpd="sng" algn="ctr">
+                      <a:solidFill>
+                        <a:srgbClr val="000000"/>
+                      </a:solidFill>
+                      <a:prstDash val="solid"/>
+                    </a:lnR>
+                    <a:lnT w="12700" cap="flat" cmpd="sng" algn="ctr">
+                      <a:solidFill>
+                        <a:srgbClr val="000000"/>
+                      </a:solidFill>
+                      <a:prstDash val="solid"/>
+                    </a:lnT>
+                    <a:lnB w="12700" cap="flat" cmpd="sng" algn="ctr">
+                      <a:solidFill>
+                        <a:srgbClr val="000000"/>
+                      </a:solidFill>
+                      <a:prstDash val="solid"/>
+                    </a:lnB>
+                  </a:tcPr>
+                </a:tc>
+                <a:tc>
+                  <a:txBody>
+                    <a:bodyPr wrap="square"/>
+                    <a:lstStyle/>
+                    <a:p>
+                      <a:r>
+                        <a:rPr sz="2000" b="0">
+                          <a:solidFill>
+                            <a:srgbClr val="000000"/>
+                          </a:solidFill>
+                          <a:latin typeface="Arial"/>
+                        </a:rPr>
+                        <a:t>9</a:t>
+                      </a:r>
+                    </a:p>
+                  </a:txBody>
+                  <a:tcPr marL="73152" marR="73152" marT="36576" marB="36576">
+                    <a:solidFill>
+                      <a:srgbClr val="FFFFFF"/>
+                    </a:solidFill>
+                    <a:lnL w="12700" cap="flat" cmpd="sng" algn="ctr">
+                      <a:solidFill>
+                        <a:srgbClr val="000000"/>
+                      </a:solidFill>
+                      <a:prstDash val="solid"/>
+                    </a:lnL>
+                    <a:lnR w="12700" cap="flat" cmpd="sng" algn="ctr">
+                      <a:solidFill>
+                        <a:srgbClr val="000000"/>
+                      </a:solidFill>
+                      <a:prstDash val="solid"/>
+                    </a:lnR>
+                    <a:lnT w="12700" cap="flat" cmpd="sng" algn="ctr">
+                      <a:solidFill>
+                        <a:srgbClr val="000000"/>
+                      </a:solidFill>
+                      <a:prstDash val="solid"/>
+                    </a:lnT>
+                    <a:lnB w="12700" cap="flat" cmpd="sng" algn="ctr">
+                      <a:solidFill>
+                        <a:srgbClr val="000000"/>
+                      </a:solidFill>
+                      <a:prstDash val="solid"/>
+                    </a:lnB>
+                  </a:tcPr>
+                </a:tc>
+              </a:tr>
+              <a:tr h="548640">
+                <a:tc>
+                  <a:txBody>
+                    <a:bodyPr wrap="square"/>
+                    <a:lstStyle/>
+                    <a:p>
+                      <a:r>
+                        <a:rPr sz="2000" b="0">
+                          <a:solidFill>
+                            <a:srgbClr val="000000"/>
+                          </a:solidFill>
+                          <a:latin typeface="Arial"/>
+                        </a:rPr>
+                        <a:t>5.  Data, framework, models, and evaluation</a:t>
+                      </a:r>
+                    </a:p>
+                  </a:txBody>
+                  <a:tcPr marL="73152" marR="73152" marT="36576" marB="36576">
+                    <a:solidFill>
+                      <a:srgbClr val="FFFFFF"/>
+                    </a:solidFill>
+                    <a:lnL w="12700" cap="flat" cmpd="sng" algn="ctr">
+                      <a:solidFill>
+                        <a:srgbClr val="000000"/>
+                      </a:solidFill>
+                      <a:prstDash val="solid"/>
+                    </a:lnL>
+                    <a:lnR w="12700" cap="flat" cmpd="sng" algn="ctr">
+                      <a:solidFill>
+                        <a:srgbClr val="000000"/>
+                      </a:solidFill>
+                      <a:prstDash val="solid"/>
+                    </a:lnR>
+                    <a:lnT w="12700" cap="flat" cmpd="sng" algn="ctr">
+                      <a:solidFill>
+                        <a:srgbClr val="000000"/>
+                      </a:solidFill>
+                      <a:prstDash val="solid"/>
+                    </a:lnT>
+                    <a:lnB w="12700" cap="flat" cmpd="sng" algn="ctr">
+                      <a:solidFill>
+                        <a:srgbClr val="000000"/>
+                      </a:solidFill>
+                      <a:prstDash val="solid"/>
+                    </a:lnB>
+                  </a:tcPr>
+                </a:tc>
+                <a:tc>
+                  <a:txBody>
+                    <a:bodyPr wrap="square"/>
+                    <a:lstStyle/>
+                    <a:p>
+                      <a:r>
+                        <a:rPr sz="2000" b="0">
+                          <a:solidFill>
+                            <a:srgbClr val="000000"/>
+                          </a:solidFill>
+                          <a:latin typeface="Arial"/>
+                        </a:rPr>
+                        <a:t>10 - 13</a:t>
+                      </a:r>
+                    </a:p>
+                  </a:txBody>
+                  <a:tcPr marL="73152" marR="73152" marT="36576" marB="36576">
+                    <a:solidFill>
+                      <a:srgbClr val="FFFFFF"/>
+                    </a:solidFill>
+                    <a:lnL w="12700" cap="flat" cmpd="sng" algn="ctr">
+                      <a:solidFill>
+                        <a:srgbClr val="000000"/>
+                      </a:solidFill>
+                      <a:prstDash val="solid"/>
+                    </a:lnL>
+                    <a:lnR w="12700" cap="flat" cmpd="sng" algn="ctr">
+                      <a:solidFill>
+                        <a:srgbClr val="000000"/>
+                      </a:solidFill>
+                      <a:prstDash val="solid"/>
+                    </a:lnR>
+                    <a:lnT w="12700" cap="flat" cmpd="sng" algn="ctr">
+                      <a:solidFill>
+                        <a:srgbClr val="000000"/>
+                      </a:solidFill>
+                      <a:prstDash val="solid"/>
+                    </a:lnT>
+                    <a:lnB w="12700" cap="flat" cmpd="sng" algn="ctr">
+                      <a:solidFill>
+                        <a:srgbClr val="000000"/>
+                      </a:solidFill>
+                      <a:prstDash val="solid"/>
+                    </a:lnB>
+                  </a:tcPr>
+                </a:tc>
+              </a:tr>
+              <a:tr h="548640">
+                <a:tc>
+                  <a:txBody>
+                    <a:bodyPr wrap="square"/>
+                    <a:lstStyle/>
+                    <a:p>
+                      <a:r>
+                        <a:rPr sz="2000" b="0">
+                          <a:solidFill>
+                            <a:srgbClr val="000000"/>
+                          </a:solidFill>
+                          <a:latin typeface="Arial"/>
+                        </a:rPr>
+                        <a:t>6.  Expected outcomes</a:t>
+                      </a:r>
+                    </a:p>
+                  </a:txBody>
+                  <a:tcPr marL="73152" marR="73152" marT="36576" marB="36576">
+                    <a:solidFill>
+                      <a:srgbClr val="FFFFFF"/>
+                    </a:solidFill>
+                    <a:lnL w="12700" cap="flat" cmpd="sng" algn="ctr">
+                      <a:solidFill>
+                        <a:srgbClr val="000000"/>
+                      </a:solidFill>
+                      <a:prstDash val="solid"/>
+                    </a:lnL>
+                    <a:lnR w="12700" cap="flat" cmpd="sng" algn="ctr">
+                      <a:solidFill>
+                        <a:srgbClr val="000000"/>
+                      </a:solidFill>
+                      <a:prstDash val="solid"/>
+                    </a:lnR>
+                    <a:lnT w="12700" cap="flat" cmpd="sng" algn="ctr">
+                      <a:solidFill>
+                        <a:srgbClr val="000000"/>
+                      </a:solidFill>
+                      <a:prstDash val="solid"/>
+                    </a:lnT>
+                    <a:lnB w="12700" cap="flat" cmpd="sng" algn="ctr">
+                      <a:solidFill>
+                        <a:srgbClr val="000000"/>
+                      </a:solidFill>
+                      <a:prstDash val="solid"/>
+                    </a:lnB>
+                  </a:tcPr>
+                </a:tc>
+                <a:tc>
+                  <a:txBody>
+                    <a:bodyPr wrap="square"/>
+                    <a:lstStyle/>
+                    <a:p>
+                      <a:r>
+                        <a:rPr sz="2000" b="0">
+                          <a:solidFill>
+                            <a:srgbClr val="000000"/>
+                          </a:solidFill>
+                          <a:latin typeface="Arial"/>
+                        </a:rPr>
+                        <a:t>14</a:t>
+                      </a:r>
+                    </a:p>
+                  </a:txBody>
+                  <a:tcPr marL="73152" marR="73152" marT="36576" marB="36576">
+                    <a:solidFill>
+                      <a:srgbClr val="FFFFFF"/>
+                    </a:solidFill>
+                    <a:lnL w="12700" cap="flat" cmpd="sng" algn="ctr">
+                      <a:solidFill>
+                        <a:srgbClr val="000000"/>
+                      </a:solidFill>
+                      <a:prstDash val="solid"/>
+                    </a:lnL>
+                    <a:lnR w="12700" cap="flat" cmpd="sng" algn="ctr">
+                      <a:solidFill>
+                        <a:srgbClr val="000000"/>
+                      </a:solidFill>
+                      <a:prstDash val="solid"/>
+                    </a:lnR>
+                    <a:lnT w="12700" cap="flat" cmpd="sng" algn="ctr">
+                      <a:solidFill>
+                        <a:srgbClr val="000000"/>
+                      </a:solidFill>
+                      <a:prstDash val="solid"/>
+                    </a:lnT>
+                    <a:lnB w="12700" cap="flat" cmpd="sng" algn="ctr">
+                      <a:solidFill>
+                        <a:srgbClr val="000000"/>
+                      </a:solidFill>
+                      <a:prstDash val="solid"/>
+                    </a:lnB>
+                  </a:tcPr>
+                </a:tc>
+              </a:tr>
+              <a:tr h="548640">
+                <a:tc>
+                  <a:txBody>
+                    <a:bodyPr wrap="square"/>
+                    <a:lstStyle/>
+                    <a:p>
+                      <a:r>
+                        <a:rPr sz="2000" b="0">
+                          <a:solidFill>
+                            <a:srgbClr val="000000"/>
+                          </a:solidFill>
+                          <a:latin typeface="Arial"/>
+                        </a:rPr>
+                        <a:t>7.  Schedule</a:t>
+                      </a:r>
+                    </a:p>
+                  </a:txBody>
+                  <a:tcPr marL="73152" marR="73152" marT="36576" marB="36576">
+                    <a:solidFill>
+                      <a:srgbClr val="FFFFFF"/>
+                    </a:solidFill>
+                    <a:lnL w="12700" cap="flat" cmpd="sng" algn="ctr">
+                      <a:solidFill>
+                        <a:srgbClr val="000000"/>
+                      </a:solidFill>
+                      <a:prstDash val="solid"/>
+                    </a:lnL>
+                    <a:lnR w="12700" cap="flat" cmpd="sng" algn="ctr">
+                      <a:solidFill>
+                        <a:srgbClr val="000000"/>
+                      </a:solidFill>
+                      <a:prstDash val="solid"/>
+                    </a:lnR>
+                    <a:lnT w="12700" cap="flat" cmpd="sng" algn="ctr">
+                      <a:solidFill>
+                        <a:srgbClr val="000000"/>
+                      </a:solidFill>
+                      <a:prstDash val="solid"/>
+                    </a:lnT>
+                    <a:lnB w="12700" cap="flat" cmpd="sng" algn="ctr">
+                      <a:solidFill>
+                        <a:srgbClr val="000000"/>
+                      </a:solidFill>
+                      <a:prstDash val="solid"/>
+                    </a:lnB>
+                  </a:tcPr>
+                </a:tc>
+                <a:tc>
+                  <a:txBody>
+                    <a:bodyPr wrap="square"/>
+                    <a:lstStyle/>
+                    <a:p>
+                      <a:r>
+                        <a:rPr sz="2000" b="0">
+                          <a:solidFill>
+                            <a:srgbClr val="000000"/>
+                          </a:solidFill>
+                          <a:latin typeface="Arial"/>
+                        </a:rPr>
+                        <a:t>15</a:t>
+                      </a:r>
+                    </a:p>
+                  </a:txBody>
+                  <a:tcPr marL="73152" marR="73152" marT="36576" marB="36576">
+                    <a:solidFill>
+                      <a:srgbClr val="FFFFFF"/>
+                    </a:solidFill>
+                    <a:lnL w="12700" cap="flat" cmpd="sng" algn="ctr">
+                      <a:solidFill>
+                        <a:srgbClr val="000000"/>
+                      </a:solidFill>
+                      <a:prstDash val="solid"/>
+                    </a:lnL>
+                    <a:lnR w="12700" cap="flat" cmpd="sng" algn="ctr">
+                      <a:solidFill>
+                        <a:srgbClr val="000000"/>
+                      </a:solidFill>
+                      <a:prstDash val="solid"/>
+                    </a:lnR>
+                    <a:lnT w="12700" cap="flat" cmpd="sng" algn="ctr">
+                      <a:solidFill>
+                        <a:srgbClr val="000000"/>
+                      </a:solidFill>
+                      <a:prstDash val="solid"/>
+                    </a:lnT>
+                    <a:lnB w="12700" cap="flat" cmpd="sng" algn="ctr">
+                      <a:solidFill>
+                        <a:srgbClr val="000000"/>
+                      </a:solidFill>
+                      <a:prstDash val="solid"/>
+                    </a:lnB>
+                  </a:tcPr>
+                </a:tc>
+              </a:tr>
+            </a:tbl>
+          </a:graphicData>
+        </a:graphic>
+      </p:graphicFrame>
+    </p:spTree>
+  </p:cSld>
+  <p:clrMapOvr>
+    <a:masterClrMapping/>
+  </p:clrMapOvr>
+</p:sld>
+</file>
+
+<file path=ppt/slides/slide3.xml><?xml version="1.0" encoding="utf-8"?>
+<p:sld xmlns:a="http://schemas.openxmlformats.org/drawingml/2006/main" xmlns:p="http://schemas.openxmlformats.org/presentationml/2006/main" xmlns:r="http://schemas.openxmlformats.org/officeDocument/2006/relationships">
+  <p:cSld>
+    <p:spTree>
+      <p:nvGrpSpPr>
+        <p:cNvPr id="1" name=""/>
+        <p:cNvGrpSpPr/>
+        <p:nvPr/>
+      </p:nvGrpSpPr>
+      <p:grpSpPr/>
+      <p:sp>
+        <p:nvSpPr>
+          <p:cNvPr id="2" name="TextBox 1"/>
+          <p:cNvSpPr txBox="1"/>
+          <p:nvPr/>
+        </p:nvSpPr>
+        <p:spPr>
+          <a:xfrm>
+            <a:off x="548640" y="320040"/>
+            <a:ext cx="11064240" cy="822960"/>
+          </a:xfrm>
+          <a:prstGeom prst="rect">
+            <a:avLst/>
+          </a:prstGeom>
+          <a:noFill/>
+        </p:spPr>
+        <p:txBody>
+          <a:bodyPr wrap="square" anchor="ctr" lIns="45720" rIns="45720">
+            <a:spAutoFit/>
+          </a:bodyPr>
+          <a:lstStyle/>
+          <a:p>
+            <a:pPr algn="l">
+              <a:spcAft>
+                <a:spcPts val="800"/>
+              </a:spcAft>
+            </a:pPr>
+            <a:r>
+              <a:rPr sz="3200" b="1">
+                <a:solidFill>
+                  <a:srgbClr val="000000"/>
+                </a:solidFill>
+                <a:latin typeface="Arial"/>
+              </a:rPr>
+              <a:t>Project at a glance</a:t>
+            </a:r>
+          </a:p>
+        </p:txBody>
+      </p:sp>
+      <p:cxnSp>
+        <p:nvCxnSpPr>
+          <p:cNvPr id="3" name="Connector 2"/>
+          <p:cNvCxnSpPr/>
+          <p:nvPr/>
+        </p:nvCxnSpPr>
+        <p:spPr>
+          <a:xfrm>
+            <a:off x="594360" y="1143000"/>
+            <a:ext cx="10972800" cy="0"/>
+          </a:xfrm>
+          <a:prstGeom prst="line">
+            <a:avLst/>
+          </a:prstGeom>
+          <a:ln w="15875">
+            <a:solidFill>
+              <a:srgbClr val="000000"/>
+            </a:solidFill>
+          </a:ln>
+        </p:spPr>
+        <p:style>
+          <a:lnRef idx="2">
+            <a:schemeClr val="accent1"/>
+          </a:lnRef>
+          <a:fillRef idx="0">
+            <a:schemeClr val="accent1"/>
+          </a:fillRef>
+          <a:effectRef idx="1">
+            <a:schemeClr val="accent1"/>
+          </a:effectRef>
+          <a:fontRef idx="minor">
+            <a:schemeClr val="tx1"/>
+          </a:fontRef>
+        </p:style>
+      </p:cxnSp>
+      <p:sp>
+        <p:nvSpPr>
+          <p:cNvPr id="4" name="TextBox 3"/>
+          <p:cNvSpPr txBox="1"/>
+          <p:nvPr/>
+        </p:nvSpPr>
+        <p:spPr>
+          <a:xfrm>
+            <a:off x="548640" y="6400800"/>
+            <a:ext cx="8229600" cy="320040"/>
+          </a:xfrm>
+          <a:prstGeom prst="rect">
+            <a:avLst/>
+          </a:prstGeom>
+          <a:noFill/>
+        </p:spPr>
+        <p:txBody>
+          <a:bodyPr wrap="square" anchor="t" lIns="45720" rIns="45720">
+            <a:spAutoFit/>
+          </a:bodyPr>
+          <a:lstStyle/>
+          <a:p>
+            <a:pPr algn="l">
+              <a:spcAft>
+                <a:spcPts val="800"/>
+              </a:spcAft>
+            </a:pPr>
+            <a:r>
+              <a:rPr sz="1100" b="0">
+                <a:solidFill>
+                  <a:srgbClr val="595959"/>
+                </a:solidFill>
+                <a:latin typeface="Arial"/>
+              </a:rPr>
+              <a:t>Comparing CatBoost, TabPFN, and TabFM for Explainable Hair Fall Risk Prediction</a:t>
+            </a:r>
+          </a:p>
+        </p:txBody>
+      </p:sp>
+      <p:sp>
+        <p:nvSpPr>
+          <p:cNvPr id="5" name="TextBox 4"/>
+          <p:cNvSpPr txBox="1"/>
+          <p:nvPr/>
+        </p:nvSpPr>
+        <p:spPr>
+          <a:xfrm>
+            <a:off x="10698480" y="6400800"/>
+            <a:ext cx="914400" cy="320040"/>
+          </a:xfrm>
+          <a:prstGeom prst="rect">
+            <a:avLst/>
+          </a:prstGeom>
+          <a:noFill/>
+        </p:spPr>
+        <p:txBody>
+          <a:bodyPr wrap="square" anchor="t" lIns="45720" rIns="45720">
+            <a:spAutoFit/>
+          </a:bodyPr>
+          <a:lstStyle/>
+          <a:p>
+            <a:pPr algn="r">
+              <a:spcAft>
+                <a:spcPts val="800"/>
+              </a:spcAft>
+            </a:pPr>
+            <a:r>
+              <a:rPr sz="1100" b="0">
+                <a:solidFill>
+                  <a:srgbClr val="595959"/>
+                </a:solidFill>
+                <a:latin typeface="Arial"/>
+              </a:rPr>
+              <a:t>3 / 16</a:t>
             </a:r>
           </a:p>
         </p:txBody>
@@ -7373,7 +8930,7 @@
 </p:sld>
 </file>
 
-<file path=ppt/slides/slide3.xml><?xml version="1.0" encoding="utf-8"?>
+<file path=ppt/slides/slide4.xml><?xml version="1.0" encoding="utf-8"?>
 <p:sld xmlns:a="http://schemas.openxmlformats.org/drawingml/2006/main" xmlns:p="http://schemas.openxmlformats.org/presentationml/2006/main" xmlns:r="http://schemas.openxmlformats.org/officeDocument/2006/relationships">
   <p:cSld>
     <p:spTree>
@@ -7530,7 +9087,7 @@
                 </a:solidFill>
                 <a:latin typeface="Arial"/>
               </a:rPr>
-              <a:t>3 / 14</a:t>
+              <a:t>4 / 16</a:t>
             </a:r>
           </a:p>
         </p:txBody>
@@ -7646,7 +9203,7 @@
 </p:sld>
 </file>
 
-<file path=ppt/slides/slide4.xml><?xml version="1.0" encoding="utf-8"?>
+<file path=ppt/slides/slide5.xml><?xml version="1.0" encoding="utf-8"?>
 <p:sld xmlns:a="http://schemas.openxmlformats.org/drawingml/2006/main" xmlns:p="http://schemas.openxmlformats.org/presentationml/2006/main" xmlns:r="http://schemas.openxmlformats.org/officeDocument/2006/relationships">
   <p:cSld>
     <p:spTree>
@@ -7803,7 +9360,7 @@
                 </a:solidFill>
                 <a:latin typeface="Arial"/>
               </a:rPr>
-              <a:t>4 / 14</a:t>
+              <a:t>5 / 16</a:t>
             </a:r>
           </a:p>
         </p:txBody>
@@ -7871,7 +9428,7 @@
 </p:sld>
 </file>
 
-<file path=ppt/slides/slide5.xml><?xml version="1.0" encoding="utf-8"?>
+<file path=ppt/slides/slide6.xml><?xml version="1.0" encoding="utf-8"?>
 <p:sld xmlns:a="http://schemas.openxmlformats.org/drawingml/2006/main" xmlns:p="http://schemas.openxmlformats.org/presentationml/2006/main" xmlns:r="http://schemas.openxmlformats.org/officeDocument/2006/relationships">
   <p:cSld>
     <p:spTree>
@@ -8028,7 +9585,7 @@
                 </a:solidFill>
                 <a:latin typeface="Arial"/>
               </a:rPr>
-              <a:t>5 / 14</a:t>
+              <a:t>6 / 16</a:t>
             </a:r>
           </a:p>
         </p:txBody>
@@ -8947,7 +10504,7 @@
 </p:sld>
 </file>
 
-<file path=ppt/slides/slide6.xml><?xml version="1.0" encoding="utf-8"?>
+<file path=ppt/slides/slide7.xml><?xml version="1.0" encoding="utf-8"?>
 <p:sld xmlns:a="http://schemas.openxmlformats.org/drawingml/2006/main" xmlns:p="http://schemas.openxmlformats.org/presentationml/2006/main" xmlns:r="http://schemas.openxmlformats.org/officeDocument/2006/relationships">
   <p:cSld>
     <p:spTree>
@@ -9104,7 +10661,7 @@
                 </a:solidFill>
                 <a:latin typeface="Arial"/>
               </a:rPr>
-              <a:t>6 / 14</a:t>
+              <a:t>7 / 16</a:t>
             </a:r>
           </a:p>
         </p:txBody>
@@ -10486,7 +12043,7 @@
 </p:sld>
 </file>
 
-<file path=ppt/slides/slide7.xml><?xml version="1.0" encoding="utf-8"?>
+<file path=ppt/slides/slide8.xml><?xml version="1.0" encoding="utf-8"?>
 <p:sld xmlns:a="http://schemas.openxmlformats.org/drawingml/2006/main" xmlns:p="http://schemas.openxmlformats.org/presentationml/2006/main" xmlns:r="http://schemas.openxmlformats.org/officeDocument/2006/relationships">
   <p:cSld>
     <p:spTree>
@@ -10643,7 +12200,7 @@
                 </a:solidFill>
                 <a:latin typeface="Arial"/>
               </a:rPr>
-              <a:t>7 / 14</a:t>
+              <a:t>8 / 16</a:t>
             </a:r>
           </a:p>
         </p:txBody>
@@ -10759,7 +12316,7 @@
 </p:sld>
 </file>
 
-<file path=ppt/slides/slide8.xml><?xml version="1.0" encoding="utf-8"?>
+<file path=ppt/slides/slide9.xml><?xml version="1.0" encoding="utf-8"?>
 <p:sld xmlns:a="http://schemas.openxmlformats.org/drawingml/2006/main" xmlns:p="http://schemas.openxmlformats.org/presentationml/2006/main" xmlns:r="http://schemas.openxmlformats.org/officeDocument/2006/relationships">
   <p:cSld>
     <p:spTree>
@@ -10916,7 +12473,7 @@
                 </a:solidFill>
                 <a:latin typeface="Arial"/>
               </a:rPr>
-              <a:t>8 / 14</a:t>
+              <a:t>9 / 16</a:t>
             </a:r>
           </a:p>
         </p:txBody>
@@ -11024,287 +12581,6 @@
           </a:p>
         </p:txBody>
       </p:sp>
-    </p:spTree>
-  </p:cSld>
-  <p:clrMapOvr>
-    <a:masterClrMapping/>
-  </p:clrMapOvr>
-</p:sld>
-</file>
-
-<file path=ppt/slides/slide9.xml><?xml version="1.0" encoding="utf-8"?>
-<p:sld xmlns:a="http://schemas.openxmlformats.org/drawingml/2006/main" xmlns:p="http://schemas.openxmlformats.org/presentationml/2006/main" xmlns:r="http://schemas.openxmlformats.org/officeDocument/2006/relationships">
-  <p:cSld>
-    <p:spTree>
-      <p:nvGrpSpPr>
-        <p:cNvPr id="1" name=""/>
-        <p:cNvGrpSpPr/>
-        <p:nvPr/>
-      </p:nvGrpSpPr>
-      <p:grpSpPr/>
-      <p:sp>
-        <p:nvSpPr>
-          <p:cNvPr id="2" name="TextBox 1"/>
-          <p:cNvSpPr txBox="1"/>
-          <p:nvPr/>
-        </p:nvSpPr>
-        <p:spPr>
-          <a:xfrm>
-            <a:off x="548640" y="320040"/>
-            <a:ext cx="11064240" cy="822960"/>
-          </a:xfrm>
-          <a:prstGeom prst="rect">
-            <a:avLst/>
-          </a:prstGeom>
-          <a:noFill/>
-        </p:spPr>
-        <p:txBody>
-          <a:bodyPr wrap="square" anchor="ctr" lIns="45720" rIns="45720">
-            <a:spAutoFit/>
-          </a:bodyPr>
-          <a:lstStyle/>
-          <a:p>
-            <a:pPr algn="l">
-              <a:spcAft>
-                <a:spcPts val="800"/>
-              </a:spcAft>
-            </a:pPr>
-            <a:r>
-              <a:rPr sz="3200" b="1">
-                <a:solidFill>
-                  <a:srgbClr val="000000"/>
-                </a:solidFill>
-                <a:latin typeface="Arial"/>
-              </a:rPr>
-              <a:t>Data</a:t>
-            </a:r>
-          </a:p>
-        </p:txBody>
-      </p:sp>
-      <p:cxnSp>
-        <p:nvCxnSpPr>
-          <p:cNvPr id="3" name="Connector 2"/>
-          <p:cNvCxnSpPr/>
-          <p:nvPr/>
-        </p:nvCxnSpPr>
-        <p:spPr>
-          <a:xfrm>
-            <a:off x="594360" y="1143000"/>
-            <a:ext cx="10972800" cy="0"/>
-          </a:xfrm>
-          <a:prstGeom prst="line">
-            <a:avLst/>
-          </a:prstGeom>
-          <a:ln w="15875">
-            <a:solidFill>
-              <a:srgbClr val="000000"/>
-            </a:solidFill>
-          </a:ln>
-        </p:spPr>
-        <p:style>
-          <a:lnRef idx="2">
-            <a:schemeClr val="accent1"/>
-          </a:lnRef>
-          <a:fillRef idx="0">
-            <a:schemeClr val="accent1"/>
-          </a:fillRef>
-          <a:effectRef idx="1">
-            <a:schemeClr val="accent1"/>
-          </a:effectRef>
-          <a:fontRef idx="minor">
-            <a:schemeClr val="tx1"/>
-          </a:fontRef>
-        </p:style>
-      </p:cxnSp>
-      <p:sp>
-        <p:nvSpPr>
-          <p:cNvPr id="4" name="TextBox 3"/>
-          <p:cNvSpPr txBox="1"/>
-          <p:nvPr/>
-        </p:nvSpPr>
-        <p:spPr>
-          <a:xfrm>
-            <a:off x="548640" y="6400800"/>
-            <a:ext cx="8229600" cy="320040"/>
-          </a:xfrm>
-          <a:prstGeom prst="rect">
-            <a:avLst/>
-          </a:prstGeom>
-          <a:noFill/>
-        </p:spPr>
-        <p:txBody>
-          <a:bodyPr wrap="square" anchor="t" lIns="45720" rIns="45720">
-            <a:spAutoFit/>
-          </a:bodyPr>
-          <a:lstStyle/>
-          <a:p>
-            <a:pPr algn="l">
-              <a:spcAft>
-                <a:spcPts val="800"/>
-              </a:spcAft>
-            </a:pPr>
-            <a:r>
-              <a:rPr sz="1100" b="0">
-                <a:solidFill>
-                  <a:srgbClr val="595959"/>
-                </a:solidFill>
-                <a:latin typeface="Arial"/>
-              </a:rPr>
-              <a:t>Comparing CatBoost, TabPFN, and TabFM for Explainable Hair Fall Risk Prediction</a:t>
-            </a:r>
-          </a:p>
-        </p:txBody>
-      </p:sp>
-      <p:sp>
-        <p:nvSpPr>
-          <p:cNvPr id="5" name="TextBox 4"/>
-          <p:cNvSpPr txBox="1"/>
-          <p:nvPr/>
-        </p:nvSpPr>
-        <p:spPr>
-          <a:xfrm>
-            <a:off x="10698480" y="6400800"/>
-            <a:ext cx="914400" cy="320040"/>
-          </a:xfrm>
-          <a:prstGeom prst="rect">
-            <a:avLst/>
-          </a:prstGeom>
-          <a:noFill/>
-        </p:spPr>
-        <p:txBody>
-          <a:bodyPr wrap="square" anchor="t" lIns="45720" rIns="45720">
-            <a:spAutoFit/>
-          </a:bodyPr>
-          <a:lstStyle/>
-          <a:p>
-            <a:pPr algn="r">
-              <a:spcAft>
-                <a:spcPts val="800"/>
-              </a:spcAft>
-            </a:pPr>
-            <a:r>
-              <a:rPr sz="1100" b="0">
-                <a:solidFill>
-                  <a:srgbClr val="595959"/>
-                </a:solidFill>
-                <a:latin typeface="Arial"/>
-              </a:rPr>
-              <a:t>9 / 14</a:t>
-            </a:r>
-          </a:p>
-        </p:txBody>
-      </p:sp>
-      <p:sp>
-        <p:nvSpPr>
-          <p:cNvPr id="6" name="TextBox 5"/>
-          <p:cNvSpPr txBox="1"/>
-          <p:nvPr/>
-        </p:nvSpPr>
-        <p:spPr>
-          <a:xfrm>
-            <a:off x="548640" y="1371600"/>
-            <a:ext cx="4572000" cy="4846320"/>
-          </a:xfrm>
-          <a:prstGeom prst="rect">
-            <a:avLst/>
-          </a:prstGeom>
-          <a:noFill/>
-        </p:spPr>
-        <p:txBody>
-          <a:bodyPr wrap="square" anchor="t" lIns="45720" rIns="45720">
-            <a:spAutoFit/>
-          </a:bodyPr>
-          <a:lstStyle/>
-          <a:p>
-            <a:pPr algn="l">
-              <a:spcAft>
-                <a:spcPts val="1200"/>
-              </a:spcAft>
-            </a:pPr>
-            <a:r>
-              <a:rPr sz="1700" b="0">
-                <a:solidFill>
-                  <a:srgbClr val="000000"/>
-                </a:solidFill>
-                <a:latin typeface="Arial"/>
-              </a:rPr>
-              <a:t>•  Dataset 1 (Kaggle): 100,000 records, 13 columns of measurements and hair fall (0 to 5).</a:t>
-            </a:r>
-          </a:p>
-          <a:p>
-            <a:pPr algn="l">
-              <a:spcAft>
-                <a:spcPts val="1200"/>
-              </a:spcAft>
-            </a:pPr>
-            <a:r>
-              <a:rPr sz="1700" b="0">
-                <a:solidFill>
-                  <a:srgbClr val="000000"/>
-                </a:solidFill>
-                <a:latin typeface="Arial"/>
-              </a:rPr>
-              <a:t>•  Dataset 2 (Mendeley): survey of 716 people, 14 columns.</a:t>
-            </a:r>
-          </a:p>
-          <a:p>
-            <a:pPr algn="l">
-              <a:spcAft>
-                <a:spcPts val="1200"/>
-              </a:spcAft>
-            </a:pPr>
-            <a:r>
-              <a:rPr sz="1700" b="0">
-                <a:solidFill>
-                  <a:srgbClr val="000000"/>
-                </a:solidFill>
-                <a:latin typeface="Arial"/>
-              </a:rPr>
-              <a:t>•  Super dataset: 200,000 records with all fields of both and extra fields.</a:t>
-            </a:r>
-          </a:p>
-          <a:p>
-            <a:pPr algn="l">
-              <a:spcAft>
-                <a:spcPts val="1200"/>
-              </a:spcAft>
-            </a:pPr>
-            <a:r>
-              <a:rPr sz="1700" b="0">
-                <a:solidFill>
-                  <a:srgbClr val="000000"/>
-                </a:solidFill>
-                <a:latin typeface="Arial"/>
-              </a:rPr>
-              <a:t>•  Final dataset: 21,606 records, 20 features, target Low 45%, Moderate 35%, High 20%.</a:t>
-            </a:r>
-          </a:p>
-        </p:txBody>
-      </p:sp>
-      <p:pic>
-        <p:nvPicPr>
-          <p:cNvPr id="7" name="Picture 6" descr="fig_3_2_dataset_link.png"/>
-          <p:cNvPicPr>
-            <a:picLocks noChangeAspect="1"/>
-          </p:cNvPicPr>
-          <p:nvPr/>
-        </p:nvPicPr>
-        <p:blipFill>
-          <a:blip r:embed="rId3"/>
-          <a:stretch>
-            <a:fillRect/>
-          </a:stretch>
-        </p:blipFill>
-        <p:spPr>
-          <a:xfrm>
-            <a:off x="5212080" y="2194560"/>
-            <a:ext cx="6675120" cy="2853550"/>
-          </a:xfrm>
-          <a:prstGeom prst="rect">
-            <a:avLst/>
-          </a:prstGeom>
-        </p:spPr>
-      </p:pic>
     </p:spTree>
   </p:cSld>
   <p:clrMapOvr>

</xml_diff>